<commit_message>
Eigen upgrade-ideeën van Dustin verwerkt in de bestaande slides
Geen nieuwe slides, het deck blijft 16 slides.

- Slide 12: kwaliteit draait nu om veilige mesjes, scheerkoppen die een baard
  van drie dagen scheren en accu's. Nieuwe modellen: slim lcd-display en nieuwe
  printplaat (zoals de Manscaped Gen 6), een behuizing van legering en USB-C met
  siliconen klepje.
- Slide 13: een adapter die precies de juiste stroom levert, en USB-C op elk
  product met een siliconen klepje.
- Slides 14 en 15: per product de ideeën uitgewerkt (Elite USB-C en adapter,
  koppen voor een baard van drie dagen, Pro naar Li-ion en USB-C).
- Slide 15: schets van het nieuwe mesje voor de bodygroomers, met R-vormige
  punten die iets naar beneden buigen en een teruggezet bewegend mes.
- Slotslide vraagt de fabrieken welke nieuwe functies ze kunnen bieden.

Co-Authored-By: Claude Opus 5.5 <noreply@anthropic.com>
Claude-Session: https://claude.ai/code/session_01YKcRMpiL4Gas7FwYTKCw5d
</commit_message>
<xml_diff>
--- a/presentaties/fabrieksbezoek-china-2026/uitvoer/Wellshave_Factory_Visit_iClipper.pptx
+++ b/presentaties/fabrieksbezoek-china-2026/uitvoer/Wellshave_Factory_Visit_iClipper.pptx
@@ -115,30 +115,30 @@
   <p:extLst>
     <p:ext uri="{521415D9-36F7-43E2-AB2F-B90AF26B5E84}">
       <p14:sectionLst xmlns:p14="http://schemas.microsoft.com/office/powerpoint/2010/main">
-        <p14:section name="Introduction" id="{4ec675a4-7172-65f2-40a7-c7689537cb82}">
+        <p14:section name="Introduction" id="{c74123f7-8e3f-a9d0-14d3-0aae4edda59a}">
           <p14:sldIdLst>
             <p14:sldId id="256"/>
           </p14:sldIdLst>
         </p14:section>
-        <p14:section name="About Wellshave" id="{45189cb7-47ff-e40c-62e6-a4950725b30b}">
+        <p14:section name="About Wellshave" id="{b5cb6749-1dc1-c413-c036-7b1a8e7a8877}">
           <p14:sldIdLst>
             <p14:sldId id="257"/>
             <p14:sldId id="258"/>
           </p14:sldIdLst>
         </p14:section>
-        <p14:section name="The visit" id="{8fb12f8d-50c9-e356-bfea-7fff716660ee}">
+        <p14:section name="The visit" id="{60dc327e-25e6-f449-3d91-fbedd2c75bb2}">
           <p14:sldIdLst>
             <p14:sldId id="259"/>
             <p14:sldId id="260"/>
           </p14:sldIdLst>
         </p14:section>
-        <p14:section name="Your products" id="{cdeb3677-ed78-689c-6ecc-e2d5029bc11a}">
+        <p14:section name="Your products" id="{92dc8619-340f-fa90-fcdb-675e20dd234d}">
           <p14:sldIdLst>
             <p14:sldId id="261"/>
             <p14:sldId id="262"/>
           </p14:sldIdLst>
         </p14:section>
-        <p14:section name="Working together" id="{ad9b4c1a-10a2-0984-69e2-e9970f10827e}">
+        <p14:section name="Working together" id="{c6773a04-7c1f-a9b0-81dc-f34f4470d0c3}">
           <p14:sldIdLst>
             <p14:sldId id="263"/>
             <p14:sldId id="264"/>
@@ -11617,7 +11617,7 @@
                   <a:schemeClr val="bg1"/>
                 </a:solidFill>
               </a:rPr>
-              <a:t>What sells well in other markets? What would you change in our products?</a:t>
+              <a:t>What sells well in other markets? Which new features can you offer us?</a:t>
             </a:r>
             <a:endParaRPr lang="en-US" sz="1800" dirty="0"/>
           </a:p>
@@ -11637,7 +11637,7 @@
                 <a:ea typeface="Microsoft YaHei" pitchFamily="34" charset="-122"/>
                 <a:cs typeface="Microsoft YaHei" pitchFamily="34" charset="-120"/>
               </a:rPr>
-              <a:t>哪些产品在其他市场卖得好？您会如何改进我们的产品？</a:t>
+              <a:t>哪些产品在其他市场卖得好？贵司能为我们提供哪些新功能？</a:t>
             </a:r>
             <a:endParaRPr lang="en-US" sz="1800" dirty="0"/>
           </a:p>

</xml_diff>

<commit_message>
Plannen voor 2027 in plaats van de agendaslide
De slide "Why we are visiting" is vervangen door een donkere slide over 2027: elke maand
3 tot 5 nieuwe producten, klein testen met een lage MOQ, snel leren en winnaars direct groot
inkopen, met wat we van de fabriek vragen en wat het hun oplevert. Het aantal slides blijft
gelijk (16 en 9). De vraag op de laatste slide vraagt nu ook naar nieuwe producten voor 2027.

Co-Authored-By: Claude Opus 5.5 <noreply@anthropic.com>
Claude-Session: https://claude.ai/code/session_01YKcRMpiL4Gas7FwYTKCw5d
</commit_message>
<xml_diff>
--- a/presentaties/fabrieksbezoek-china-2026/uitvoer/Wellshave_Factory_Visit_iClipper.pptx
+++ b/presentaties/fabrieksbezoek-china-2026/uitvoer/Wellshave_Factory_Visit_iClipper.pptx
@@ -115,30 +115,30 @@
   <p:extLst>
     <p:ext uri="{521415D9-36F7-43E2-AB2F-B90AF26B5E84}">
       <p14:sectionLst xmlns:p14="http://schemas.microsoft.com/office/powerpoint/2010/main">
-        <p14:section name="Introduction" id="{c74123f7-8e3f-a9d0-14d3-0aae4edda59a}">
+        <p14:section name="Introduction" id="{6dc26b53-28a3-f69c-adf8-fdc049a93736}">
           <p14:sldIdLst>
             <p14:sldId id="256"/>
           </p14:sldIdLst>
         </p14:section>
-        <p14:section name="About Wellshave" id="{b5cb6749-1dc1-c413-c036-7b1a8e7a8877}">
+        <p14:section name="About Wellshave" id="{83e6b5b8-846b-6e13-9a0f-72cb9ffe73fd}">
           <p14:sldIdLst>
             <p14:sldId id="257"/>
             <p14:sldId id="258"/>
           </p14:sldIdLst>
         </p14:section>
-        <p14:section name="The visit" id="{60dc327e-25e6-f449-3d91-fbedd2c75bb2}">
+        <p14:section name="The visit" id="{901449b2-6ee7-92c9-2715-82422ef2f874}">
           <p14:sldIdLst>
             <p14:sldId id="259"/>
             <p14:sldId id="260"/>
           </p14:sldIdLst>
         </p14:section>
-        <p14:section name="Your products" id="{92dc8619-340f-fa90-fcdb-675e20dd234d}">
+        <p14:section name="Your products" id="{59695592-0d03-c88c-8296-84597ffd59e3}">
           <p14:sldIdLst>
             <p14:sldId id="261"/>
             <p14:sldId id="262"/>
           </p14:sldIdLst>
         </p14:section>
-        <p14:section name="Working together" id="{c6773a04-7c1f-a9b0-81dc-f34f4470d0c3}">
+        <p14:section name="Working together" id="{22cada9d-e55f-e910-8ace-78a377e6b98c}">
           <p14:sldIdLst>
             <p14:sldId id="263"/>
             <p14:sldId id="264"/>
@@ -900,7 +900,7 @@
           <a:p>
             <a:r>
               <a:rPr lang="en-US" dirty="0"/>
-              <a:t/>
+              <a:t>This is the main message of the visit: in 2027 we launch 3 to 5 new products every month, so 36 to 60 in the year. We test every new product with a small first order, read the sales quickly, and scale the winners straight away with large bulk orders. Questions for the factory: what is the lowest MOQ you can do for a first test order? How fast can you make a sample? How fast can you deliver a large reorder when a product takes off? Which of your new products would you put forward first?</a:t>
             </a:r>
             <a:endParaRPr lang="en-US" dirty="0"/>
           </a:p>
@@ -5872,10 +5872,10 @@
             <a:r>
               <a:rPr lang="en-US" sz="3200" b="1" dirty="0">
                 <a:solidFill>
-                  <a:schemeClr val="tx1"/>
-                </a:solidFill>
-              </a:rPr>
-              <a:t>Why we are visiting</a:t>
+                  <a:schemeClr val="bg1"/>
+                </a:solidFill>
+              </a:rPr>
+              <a:t>Our plans for 2027: more products, faster</a:t>
             </a:r>
             <a:endParaRPr lang="en-US" sz="3200" dirty="0"/>
           </a:p>
@@ -5910,13 +5910,13 @@
             <a:r>
               <a:rPr lang="en-US" sz="2000" b="1" dirty="0">
                 <a:solidFill>
-                  <a:schemeClr val="accent1"/>
+                  <a:schemeClr val="accent2"/>
                 </a:solidFill>
                 <a:latin typeface="Microsoft YaHei" pitchFamily="34" charset="0"/>
                 <a:ea typeface="Microsoft YaHei" pitchFamily="34" charset="-122"/>
                 <a:cs typeface="Microsoft YaHei" pitchFamily="34" charset="-120"/>
               </a:rPr>
-              <a:t>本次拜访目的</a:t>
+              <a:t>2027 年计划：更多新品，更快速度</a:t>
             </a:r>
             <a:endParaRPr lang="en-US" sz="2000" dirty="0"/>
           </a:p>
@@ -5924,36 +5924,36 @@
       </p:sp>
       <p:sp>
         <p:nvSpPr>
-          <p:cNvPr id="4" name="Step card 1"/>
+          <p:cNvPr id="4" name="Pace card"/>
           <p:cNvSpPr/>
           <p:nvPr/>
         </p:nvSpPr>
         <p:spPr>
           <a:xfrm>
-            <a:off x="548640" y="1783080"/>
-            <a:ext cx="2609012" cy="3154680"/>
+            <a:off x="548640" y="1755648"/>
+            <a:ext cx="2971800" cy="2971800"/>
           </a:xfrm>
           <a:prstGeom prst="roundRect">
             <a:avLst>
-              <a:gd name="adj" fmla="val 5608"/>
+              <a:gd name="adj" fmla="val 4923"/>
             </a:avLst>
           </a:prstGeom>
           <a:solidFill>
-            <a:srgbClr val="FFFFFF"/>
+            <a:srgbClr val="F5D18A"/>
           </a:solidFill>
           <a:ln/>
         </p:spPr>
       </p:sp>
       <p:sp>
         <p:nvSpPr>
-          <p:cNvPr id="5" name="Step number 1"/>
+          <p:cNvPr id="5" name="Pace eyebrow"/>
           <p:cNvSpPr txBox="1"/>
           <p:nvPr/>
         </p:nvSpPr>
         <p:spPr>
           <a:xfrm>
-            <a:off x="804672" y="2039112"/>
-            <a:ext cx="914400" cy="548640"/>
+            <a:off x="822960" y="2029968"/>
+            <a:ext cx="2514600" cy="256032"/>
           </a:xfrm>
           <a:prstGeom prst="rect">
             <a:avLst/>
@@ -5969,86 +5969,41 @@
               <a:buNone/>
             </a:pPr>
             <a:r>
-              <a:rPr lang="en-US" sz="3200" b="1" dirty="0">
-                <a:solidFill>
-                  <a:schemeClr val="accent1"/>
-                </a:solidFill>
-              </a:rPr>
-              <a:t>01</a:t>
-            </a:r>
-            <a:endParaRPr lang="en-US" sz="3200" dirty="0"/>
-          </a:p>
-        </p:txBody>
-      </p:sp>
-      <p:sp>
-        <p:nvSpPr>
-          <p:cNvPr id="6" name="Step title 1"/>
-          <p:cNvSpPr txBox="1"/>
-          <p:nvPr/>
-        </p:nvSpPr>
-        <p:spPr>
-          <a:xfrm>
-            <a:off x="804672" y="2697480"/>
-            <a:ext cx="2151812" cy="868680"/>
-          </a:xfrm>
-          <a:prstGeom prst="rect">
-            <a:avLst/>
-          </a:prstGeom>
-          <a:noFill/>
-          <a:ln/>
-        </p:spPr>
-        <p:txBody>
-          <a:bodyPr wrap="square" lIns="0" tIns="0" rIns="0" bIns="0" rtlCol="0" anchor="t"/>
-          <a:lstStyle/>
-          <a:p>
-            <a:pPr indent="0" marL="0">
-              <a:spcAft>
-                <a:spcPts val="300"/>
-              </a:spcAft>
-              <a:buNone/>
-            </a:pPr>
-            <a:r>
-              <a:rPr lang="en-US" sz="1600" b="1" dirty="0">
-                <a:solidFill>
-                  <a:schemeClr val="tx1"/>
-                </a:solidFill>
-              </a:rPr>
-              <a:t>Get to know each other</a:t>
-            </a:r>
-            <a:endParaRPr lang="en-US" sz="1600" dirty="0"/>
-          </a:p>
-          <a:p>
-            <a:pPr indent="0" marL="0">
-              <a:spcAft>
-                <a:spcPts val="300"/>
-              </a:spcAft>
-              <a:buNone/>
-            </a:pPr>
-            <a:r>
-              <a:rPr lang="en-US" sz="1500" b="1" dirty="0">
-                <a:solidFill>
-                  <a:schemeClr val="accent1"/>
+              <a:rPr lang="en-US" sz="1000" b="1" spc="200" kern="0" dirty="0">
+                <a:solidFill>
+                  <a:schemeClr val="accent4"/>
+                </a:solidFill>
+              </a:rPr>
+              <a:t>EVERY MONTH</a:t>
+            </a:r>
+            <a:pPr indent="0" marL="0">
+              <a:buNone/>
+            </a:pPr>
+            <a:r>
+              <a:rPr lang="en-US" sz="1000" b="1" dirty="0">
+                <a:solidFill>
+                  <a:schemeClr val="accent4"/>
                 </a:solidFill>
                 <a:latin typeface="Microsoft YaHei" pitchFamily="34" charset="0"/>
                 <a:ea typeface="Microsoft YaHei" pitchFamily="34" charset="-122"/>
                 <a:cs typeface="Microsoft YaHei" pitchFamily="34" charset="-120"/>
               </a:rPr>
-              <a:t>相互了解</a:t>
-            </a:r>
-            <a:endParaRPr lang="en-US" sz="1600" dirty="0"/>
-          </a:p>
-        </p:txBody>
-      </p:sp>
-      <p:sp>
-        <p:nvSpPr>
-          <p:cNvPr id="7" name="Step text 1"/>
+              <a:t>  ·  每月</a:t>
+            </a:r>
+            <a:endParaRPr lang="en-US" sz="1000" dirty="0"/>
+          </a:p>
+        </p:txBody>
+      </p:sp>
+      <p:sp>
+        <p:nvSpPr>
+          <p:cNvPr id="6" name="Pace value"/>
           <p:cNvSpPr txBox="1"/>
           <p:nvPr/>
         </p:nvSpPr>
         <p:spPr>
           <a:xfrm>
-            <a:off x="804672" y="3611880"/>
-            <a:ext cx="2197532" cy="1234440"/>
+            <a:off x="822960" y="2322576"/>
+            <a:ext cx="2514600" cy="777240"/>
           </a:xfrm>
           <a:prstGeom prst="rect">
             <a:avLst/>
@@ -6061,75 +6016,112 @@
           <a:lstStyle/>
           <a:p>
             <a:pPr indent="0" marL="0">
-              <a:spcAft>
-                <a:spcPts val="500"/>
-              </a:spcAft>
-              <a:buNone/>
-            </a:pPr>
-            <a:r>
-              <a:rPr lang="en-US" sz="1300" dirty="0">
+              <a:buNone/>
+            </a:pPr>
+            <a:r>
+              <a:rPr lang="en-US" sz="4600" b="1" dirty="0">
                 <a:solidFill>
                   <a:schemeClr val="tx1"/>
                 </a:solidFill>
               </a:rPr>
-              <a:t>We introduce Wellshave, our customers and how we work.</a:t>
-            </a:r>
-            <a:endParaRPr lang="en-US" sz="1300" dirty="0"/>
-          </a:p>
-          <a:p>
-            <a:pPr indent="0" marL="0">
-              <a:spcAft>
-                <a:spcPts val="500"/>
-              </a:spcAft>
-              <a:buNone/>
-            </a:pPr>
-            <a:r>
-              <a:rPr lang="en-US" sz="1300" dirty="0">
-                <a:solidFill>
-                  <a:schemeClr val="accent6"/>
+              <a:t>3 to 5</a:t>
+            </a:r>
+            <a:endParaRPr lang="en-US" sz="4600" dirty="0"/>
+          </a:p>
+        </p:txBody>
+      </p:sp>
+      <p:sp>
+        <p:nvSpPr>
+          <p:cNvPr id="7" name="Pace label"/>
+          <p:cNvSpPr txBox="1"/>
+          <p:nvPr/>
+        </p:nvSpPr>
+        <p:spPr>
+          <a:xfrm>
+            <a:off x="822960" y="3127248"/>
+            <a:ext cx="2514600" cy="685800"/>
+          </a:xfrm>
+          <a:prstGeom prst="rect">
+            <a:avLst/>
+          </a:prstGeom>
+          <a:noFill/>
+          <a:ln/>
+        </p:spPr>
+        <p:txBody>
+          <a:bodyPr wrap="square" lIns="0" tIns="0" rIns="0" bIns="0" rtlCol="0" anchor="t"/>
+          <a:lstStyle/>
+          <a:p>
+            <a:pPr indent="0" marL="0">
+              <a:spcAft>
+                <a:spcPts val="200"/>
+              </a:spcAft>
+              <a:buNone/>
+            </a:pPr>
+            <a:r>
+              <a:rPr lang="en-US" sz="1800" b="1" dirty="0">
+                <a:solidFill>
+                  <a:schemeClr val="tx1"/>
+                </a:solidFill>
+              </a:rPr>
+              <a:t>new products</a:t>
+            </a:r>
+            <a:endParaRPr lang="en-US" sz="1800" dirty="0"/>
+          </a:p>
+          <a:p>
+            <a:pPr indent="0" marL="0">
+              <a:spcAft>
+                <a:spcPts val="200"/>
+              </a:spcAft>
+              <a:buNone/>
+            </a:pPr>
+            <a:r>
+              <a:rPr lang="en-US" sz="1400" dirty="0">
+                <a:solidFill>
+                  <a:schemeClr val="accent4"/>
                 </a:solidFill>
                 <a:latin typeface="Microsoft YaHei" pitchFamily="34" charset="0"/>
                 <a:ea typeface="Microsoft YaHei" pitchFamily="34" charset="-122"/>
                 <a:cs typeface="Microsoft YaHei" pitchFamily="34" charset="-120"/>
               </a:rPr>
-              <a:t>介绍 Wellshave、我们的客户和工作方式。</a:t>
-            </a:r>
-            <a:endParaRPr lang="en-US" sz="1300" dirty="0"/>
-          </a:p>
-        </p:txBody>
-      </p:sp>
-      <p:sp>
-        <p:nvSpPr>
-          <p:cNvPr id="8" name="Step card 2"/>
+              <a:t>每月推出 3 至 5 款新品</a:t>
+            </a:r>
+            <a:endParaRPr lang="en-US" sz="1800" dirty="0"/>
+          </a:p>
+        </p:txBody>
+      </p:sp>
+      <p:sp>
+        <p:nvSpPr>
+          <p:cNvPr id="8" name="Pace divider"/>
           <p:cNvSpPr/>
           <p:nvPr/>
         </p:nvSpPr>
         <p:spPr>
           <a:xfrm>
-            <a:off x="3377108" y="1783080"/>
-            <a:ext cx="2609012" cy="3154680"/>
-          </a:xfrm>
-          <a:prstGeom prst="roundRect">
-            <a:avLst>
-              <a:gd name="adj" fmla="val 5608"/>
-            </a:avLst>
-          </a:prstGeom>
-          <a:solidFill>
-            <a:srgbClr val="FFFFFF"/>
-          </a:solidFill>
-          <a:ln/>
-        </p:spPr>
-      </p:sp>
-      <p:sp>
-        <p:nvSpPr>
-          <p:cNvPr id="9" name="Step number 2"/>
+            <a:off x="822960" y="3931920"/>
+            <a:ext cx="2423160" cy="0"/>
+          </a:xfrm>
+          <a:prstGeom prst="line">
+            <a:avLst/>
+          </a:prstGeom>
+          <a:noFill/>
+          <a:ln w="12700">
+            <a:solidFill>
+              <a:schemeClr val="accent1"/>
+            </a:solidFill>
+            <a:prstDash val="solid"/>
+          </a:ln>
+        </p:spPr>
+      </p:sp>
+      <p:sp>
+        <p:nvSpPr>
+          <p:cNvPr id="9" name="Pace year"/>
           <p:cNvSpPr txBox="1"/>
           <p:nvPr/>
         </p:nvSpPr>
         <p:spPr>
           <a:xfrm>
-            <a:off x="3633140" y="2039112"/>
-            <a:ext cx="914400" cy="548640"/>
+            <a:off x="822960" y="4041648"/>
+            <a:ext cx="2514600" cy="548640"/>
           </a:xfrm>
           <a:prstGeom prst="rect">
             <a:avLst/>
@@ -6142,515 +6134,88 @@
           <a:lstStyle/>
           <a:p>
             <a:pPr indent="0" marL="0">
-              <a:buNone/>
-            </a:pPr>
-            <a:r>
-              <a:rPr lang="en-US" sz="3200" b="1" dirty="0">
-                <a:solidFill>
-                  <a:schemeClr val="accent1"/>
-                </a:solidFill>
-              </a:rPr>
-              <a:t>02</a:t>
-            </a:r>
-            <a:endParaRPr lang="en-US" sz="3200" dirty="0"/>
-          </a:p>
-        </p:txBody>
-      </p:sp>
-      <p:sp>
-        <p:nvSpPr>
-          <p:cNvPr id="10" name="Step title 2"/>
-          <p:cNvSpPr txBox="1"/>
-          <p:nvPr/>
-        </p:nvSpPr>
-        <p:spPr>
-          <a:xfrm>
-            <a:off x="3633140" y="2697480"/>
-            <a:ext cx="2151812" cy="868680"/>
-          </a:xfrm>
-          <a:prstGeom prst="rect">
-            <a:avLst/>
-          </a:prstGeom>
-          <a:noFill/>
-          <a:ln/>
-        </p:spPr>
-        <p:txBody>
-          <a:bodyPr wrap="square" lIns="0" tIns="0" rIns="0" bIns="0" rtlCol="0" anchor="t"/>
-          <a:lstStyle/>
-          <a:p>
-            <a:pPr indent="0" marL="0">
-              <a:spcAft>
-                <a:spcPts val="300"/>
-              </a:spcAft>
-              <a:buNone/>
-            </a:pPr>
-            <a:r>
-              <a:rPr lang="en-US" sz="1600" b="1" dirty="0">
+              <a:spcAft>
+                <a:spcPts val="200"/>
+              </a:spcAft>
+              <a:buNone/>
+            </a:pPr>
+            <a:r>
+              <a:rPr lang="en-US" sz="1200" b="1" dirty="0">
                 <a:solidFill>
                   <a:schemeClr val="tx1"/>
                 </a:solidFill>
               </a:rPr>
-              <a:t>Review current data</a:t>
-            </a:r>
-            <a:endParaRPr lang="en-US" sz="1600" dirty="0"/>
-          </a:p>
-          <a:p>
-            <a:pPr indent="0" marL="0">
-              <a:spcAft>
-                <a:spcPts val="300"/>
-              </a:spcAft>
-              <a:buNone/>
-            </a:pPr>
-            <a:r>
-              <a:rPr lang="en-US" sz="1500" b="1" dirty="0">
-                <a:solidFill>
-                  <a:schemeClr val="accent1"/>
+              <a:t>36 to 60 new products in 2027</a:t>
+            </a:r>
+            <a:endParaRPr lang="en-US" sz="1200" dirty="0"/>
+          </a:p>
+          <a:p>
+            <a:pPr indent="0" marL="0">
+              <a:spcAft>
+                <a:spcPts val="200"/>
+              </a:spcAft>
+              <a:buNone/>
+            </a:pPr>
+            <a:r>
+              <a:rPr lang="en-US" sz="1200" dirty="0">
+                <a:solidFill>
+                  <a:schemeClr val="accent4"/>
                 </a:solidFill>
                 <a:latin typeface="Microsoft YaHei" pitchFamily="34" charset="0"/>
                 <a:ea typeface="Microsoft YaHei" pitchFamily="34" charset="-122"/>
                 <a:cs typeface="Microsoft YaHei" pitchFamily="34" charset="-120"/>
               </a:rPr>
-              <a:t>回顾当前数据</a:t>
-            </a:r>
-            <a:endParaRPr lang="en-US" sz="1600" dirty="0"/>
-          </a:p>
-        </p:txBody>
-      </p:sp>
-      <p:sp>
-        <p:nvSpPr>
-          <p:cNvPr id="11" name="Step text 2"/>
-          <p:cNvSpPr txBox="1"/>
-          <p:nvPr/>
-        </p:nvSpPr>
-        <p:spPr>
-          <a:xfrm>
-            <a:off x="3633140" y="3611880"/>
-            <a:ext cx="2197532" cy="1234440"/>
-          </a:xfrm>
-          <a:prstGeom prst="rect">
-            <a:avLst/>
-          </a:prstGeom>
-          <a:noFill/>
-          <a:ln/>
-        </p:spPr>
-        <p:txBody>
-          <a:bodyPr wrap="square" lIns="0" tIns="0" rIns="0" bIns="0" rtlCol="0" anchor="t"/>
-          <a:lstStyle/>
-          <a:p>
-            <a:pPr indent="0" marL="0">
-              <a:spcAft>
-                <a:spcPts val="500"/>
-              </a:spcAft>
-              <a:buNone/>
-            </a:pPr>
-            <a:r>
-              <a:rPr lang="en-US" sz="1300" dirty="0">
-                <a:solidFill>
-                  <a:schemeClr val="tx1"/>
-                </a:solidFill>
-              </a:rPr>
-              <a:t>Sales, reviews and returns of the products we buy from you.</a:t>
-            </a:r>
-            <a:endParaRPr lang="en-US" sz="1300" dirty="0"/>
-          </a:p>
-          <a:p>
-            <a:pPr indent="0" marL="0">
-              <a:spcAft>
-                <a:spcPts val="500"/>
-              </a:spcAft>
-              <a:buNone/>
-            </a:pPr>
-            <a:r>
-              <a:rPr lang="en-US" sz="1300" dirty="0">
-                <a:solidFill>
-                  <a:schemeClr val="accent6"/>
-                </a:solidFill>
-                <a:latin typeface="Microsoft YaHei" pitchFamily="34" charset="0"/>
-                <a:ea typeface="Microsoft YaHei" pitchFamily="34" charset="-122"/>
-                <a:cs typeface="Microsoft YaHei" pitchFamily="34" charset="-120"/>
-              </a:rPr>
-              <a:t>回顾我们向贵司采购产品的销量、评价和退货情况。</a:t>
-            </a:r>
-            <a:endParaRPr lang="en-US" sz="1300" dirty="0"/>
-          </a:p>
-        </p:txBody>
-      </p:sp>
-      <p:sp>
-        <p:nvSpPr>
-          <p:cNvPr id="12" name="Step card 3"/>
+              <a:t>2027 年共推出 36 至 60 款新品</a:t>
+            </a:r>
+            <a:endParaRPr lang="en-US" sz="1200" dirty="0"/>
+          </a:p>
+        </p:txBody>
+      </p:sp>
+      <p:sp>
+        <p:nvSpPr>
+          <p:cNvPr id="10" name="Plan step 1"/>
           <p:cNvSpPr/>
           <p:nvPr/>
         </p:nvSpPr>
         <p:spPr>
           <a:xfrm>
-            <a:off x="6205576" y="1783080"/>
-            <a:ext cx="2609012" cy="3154680"/>
+            <a:off x="3794760" y="1755648"/>
+            <a:ext cx="2360066" cy="2971800"/>
           </a:xfrm>
           <a:prstGeom prst="roundRect">
             <a:avLst>
-              <a:gd name="adj" fmla="val 5608"/>
+              <a:gd name="adj" fmla="val 6199"/>
             </a:avLst>
           </a:prstGeom>
           <a:solidFill>
-            <a:srgbClr val="FFFFFF"/>
+            <a:srgbClr val="24221F"/>
           </a:solidFill>
           <a:ln/>
         </p:spPr>
       </p:sp>
       <p:sp>
         <p:nvSpPr>
-          <p:cNvPr id="13" name="Step number 3"/>
-          <p:cNvSpPr txBox="1"/>
-          <p:nvPr/>
-        </p:nvSpPr>
-        <p:spPr>
-          <a:xfrm>
-            <a:off x="6461608" y="2039112"/>
-            <a:ext cx="914400" cy="548640"/>
-          </a:xfrm>
-          <a:prstGeom prst="rect">
-            <a:avLst/>
-          </a:prstGeom>
-          <a:noFill/>
-          <a:ln/>
-        </p:spPr>
-        <p:txBody>
-          <a:bodyPr wrap="square" lIns="0" tIns="0" rIns="0" bIns="0" rtlCol="0" anchor="t"/>
-          <a:lstStyle/>
-          <a:p>
-            <a:pPr indent="0" marL="0">
-              <a:buNone/>
-            </a:pPr>
-            <a:r>
-              <a:rPr lang="en-US" sz="3200" b="1" dirty="0">
-                <a:solidFill>
-                  <a:schemeClr val="accent1"/>
-                </a:solidFill>
-              </a:rPr>
-              <a:t>03</a:t>
-            </a:r>
-            <a:endParaRPr lang="en-US" sz="3200" dirty="0"/>
-          </a:p>
-        </p:txBody>
-      </p:sp>
-      <p:sp>
-        <p:nvSpPr>
-          <p:cNvPr id="14" name="Step title 3"/>
-          <p:cNvSpPr txBox="1"/>
-          <p:nvPr/>
-        </p:nvSpPr>
-        <p:spPr>
-          <a:xfrm>
-            <a:off x="6461608" y="2697480"/>
-            <a:ext cx="2151812" cy="868680"/>
-          </a:xfrm>
-          <a:prstGeom prst="rect">
-            <a:avLst/>
-          </a:prstGeom>
-          <a:noFill/>
-          <a:ln/>
-        </p:spPr>
-        <p:txBody>
-          <a:bodyPr wrap="square" lIns="0" tIns="0" rIns="0" bIns="0" rtlCol="0" anchor="t"/>
-          <a:lstStyle/>
-          <a:p>
-            <a:pPr indent="0" marL="0">
-              <a:spcAft>
-                <a:spcPts val="300"/>
-              </a:spcAft>
-              <a:buNone/>
-            </a:pPr>
-            <a:r>
-              <a:rPr lang="en-US" sz="1600" b="1" dirty="0">
-                <a:solidFill>
-                  <a:schemeClr val="tx1"/>
-                </a:solidFill>
-              </a:rPr>
-              <a:t>Share our 2027 plans</a:t>
-            </a:r>
-            <a:endParaRPr lang="en-US" sz="1600" dirty="0"/>
-          </a:p>
-          <a:p>
-            <a:pPr indent="0" marL="0">
-              <a:spcAft>
-                <a:spcPts val="300"/>
-              </a:spcAft>
-              <a:buNone/>
-            </a:pPr>
-            <a:r>
-              <a:rPr lang="en-US" sz="1500" b="1" dirty="0">
-                <a:solidFill>
-                  <a:schemeClr val="accent1"/>
-                </a:solidFill>
-                <a:latin typeface="Microsoft YaHei" pitchFamily="34" charset="0"/>
-                <a:ea typeface="Microsoft YaHei" pitchFamily="34" charset="-122"/>
-                <a:cs typeface="Microsoft YaHei" pitchFamily="34" charset="-120"/>
-              </a:rPr>
-              <a:t>分享 2027 年计划</a:t>
-            </a:r>
-            <a:endParaRPr lang="en-US" sz="1600" dirty="0"/>
-          </a:p>
-        </p:txBody>
-      </p:sp>
-      <p:sp>
-        <p:nvSpPr>
-          <p:cNvPr id="15" name="Step text 3"/>
-          <p:cNvSpPr txBox="1"/>
-          <p:nvPr/>
-        </p:nvSpPr>
-        <p:spPr>
-          <a:xfrm>
-            <a:off x="6461608" y="3611880"/>
-            <a:ext cx="2197532" cy="1234440"/>
-          </a:xfrm>
-          <a:prstGeom prst="rect">
-            <a:avLst/>
-          </a:prstGeom>
-          <a:noFill/>
-          <a:ln/>
-        </p:spPr>
-        <p:txBody>
-          <a:bodyPr wrap="square" lIns="0" tIns="0" rIns="0" bIns="0" rtlCol="0" anchor="t"/>
-          <a:lstStyle/>
-          <a:p>
-            <a:pPr indent="0" marL="0">
-              <a:spcAft>
-                <a:spcPts val="500"/>
-              </a:spcAft>
-              <a:buNone/>
-            </a:pPr>
-            <a:r>
-              <a:rPr lang="en-US" sz="1300" dirty="0">
-                <a:solidFill>
-                  <a:schemeClr val="tx1"/>
-                </a:solidFill>
-              </a:rPr>
-              <a:t>Our growth plans and what they mean for your factory.</a:t>
-            </a:r>
-            <a:endParaRPr lang="en-US" sz="1300" dirty="0"/>
-          </a:p>
-          <a:p>
-            <a:pPr indent="0" marL="0">
-              <a:spcAft>
-                <a:spcPts val="500"/>
-              </a:spcAft>
-              <a:buNone/>
-            </a:pPr>
-            <a:r>
-              <a:rPr lang="en-US" sz="1300" dirty="0">
-                <a:solidFill>
-                  <a:schemeClr val="accent6"/>
-                </a:solidFill>
-                <a:latin typeface="Microsoft YaHei" pitchFamily="34" charset="0"/>
-                <a:ea typeface="Microsoft YaHei" pitchFamily="34" charset="-122"/>
-                <a:cs typeface="Microsoft YaHei" pitchFamily="34" charset="-120"/>
-              </a:rPr>
-              <a:t>我们的增长计划及其对贵厂的意义。</a:t>
-            </a:r>
-            <a:endParaRPr lang="en-US" sz="1300" dirty="0"/>
-          </a:p>
-        </p:txBody>
-      </p:sp>
-      <p:sp>
-        <p:nvSpPr>
-          <p:cNvPr id="16" name="Step card 4"/>
+          <p:cNvPr id="11" name="Plan badge 1"/>
           <p:cNvSpPr/>
           <p:nvPr/>
         </p:nvSpPr>
         <p:spPr>
           <a:xfrm>
-            <a:off x="9034043" y="1783080"/>
-            <a:ext cx="2609012" cy="3154680"/>
-          </a:xfrm>
-          <a:prstGeom prst="roundRect">
-            <a:avLst>
-              <a:gd name="adj" fmla="val 5608"/>
-            </a:avLst>
+            <a:off x="4023360" y="1984248"/>
+            <a:ext cx="566928" cy="566928"/>
+          </a:xfrm>
+          <a:prstGeom prst="ellipse">
+            <a:avLst/>
           </a:prstGeom>
           <a:solidFill>
-            <a:srgbClr val="FFFFFF"/>
-          </a:solidFill>
-          <a:ln/>
-        </p:spPr>
-      </p:sp>
-      <p:sp>
-        <p:nvSpPr>
-          <p:cNvPr id="17" name="Step number 4"/>
-          <p:cNvSpPr txBox="1"/>
-          <p:nvPr/>
-        </p:nvSpPr>
-        <p:spPr>
-          <a:xfrm>
-            <a:off x="9290075" y="2039112"/>
-            <a:ext cx="914400" cy="548640"/>
-          </a:xfrm>
-          <a:prstGeom prst="rect">
-            <a:avLst/>
-          </a:prstGeom>
-          <a:noFill/>
-          <a:ln/>
-        </p:spPr>
-        <p:txBody>
-          <a:bodyPr wrap="square" lIns="0" tIns="0" rIns="0" bIns="0" rtlCol="0" anchor="t"/>
-          <a:lstStyle/>
-          <a:p>
-            <a:pPr indent="0" marL="0">
-              <a:buNone/>
-            </a:pPr>
-            <a:r>
-              <a:rPr lang="en-US" sz="3200" b="1" dirty="0">
-                <a:solidFill>
-                  <a:schemeClr val="accent1"/>
-                </a:solidFill>
-              </a:rPr>
-              <a:t>04</a:t>
-            </a:r>
-            <a:endParaRPr lang="en-US" sz="3200" dirty="0"/>
-          </a:p>
-        </p:txBody>
-      </p:sp>
-      <p:sp>
-        <p:nvSpPr>
-          <p:cNvPr id="18" name="Step title 4"/>
-          <p:cNvSpPr txBox="1"/>
-          <p:nvPr/>
-        </p:nvSpPr>
-        <p:spPr>
-          <a:xfrm>
-            <a:off x="9290075" y="2697480"/>
-            <a:ext cx="2151812" cy="868680"/>
-          </a:xfrm>
-          <a:prstGeom prst="rect">
-            <a:avLst/>
-          </a:prstGeom>
-          <a:noFill/>
-          <a:ln/>
-        </p:spPr>
-        <p:txBody>
-          <a:bodyPr wrap="square" lIns="0" tIns="0" rIns="0" bIns="0" rtlCol="0" anchor="t"/>
-          <a:lstStyle/>
-          <a:p>
-            <a:pPr indent="0" marL="0">
-              <a:spcAft>
-                <a:spcPts val="300"/>
-              </a:spcAft>
-              <a:buNone/>
-            </a:pPr>
-            <a:r>
-              <a:rPr lang="en-US" sz="1600" b="1" dirty="0">
-                <a:solidFill>
-                  <a:schemeClr val="tx1"/>
-                </a:solidFill>
-              </a:rPr>
-              <a:t>Improve the range together</a:t>
-            </a:r>
-            <a:endParaRPr lang="en-US" sz="1600" dirty="0"/>
-          </a:p>
-          <a:p>
-            <a:pPr indent="0" marL="0">
-              <a:spcAft>
-                <a:spcPts val="300"/>
-              </a:spcAft>
-              <a:buNone/>
-            </a:pPr>
-            <a:r>
-              <a:rPr lang="en-US" sz="1500" b="1" dirty="0">
-                <a:solidFill>
-                  <a:schemeClr val="accent1"/>
-                </a:solidFill>
-                <a:latin typeface="Microsoft YaHei" pitchFamily="34" charset="0"/>
-                <a:ea typeface="Microsoft YaHei" pitchFamily="34" charset="-122"/>
-                <a:cs typeface="Microsoft YaHei" pitchFamily="34" charset="-120"/>
-              </a:rPr>
-              <a:t>共同优化产品</a:t>
-            </a:r>
-            <a:endParaRPr lang="en-US" sz="1600" dirty="0"/>
-          </a:p>
-        </p:txBody>
-      </p:sp>
-      <p:sp>
-        <p:nvSpPr>
-          <p:cNvPr id="19" name="Step text 4"/>
-          <p:cNvSpPr txBox="1"/>
-          <p:nvPr/>
-        </p:nvSpPr>
-        <p:spPr>
-          <a:xfrm>
-            <a:off x="9290075" y="3611880"/>
-            <a:ext cx="2197532" cy="1234440"/>
-          </a:xfrm>
-          <a:prstGeom prst="rect">
-            <a:avLst/>
-          </a:prstGeom>
-          <a:noFill/>
-          <a:ln/>
-        </p:spPr>
-        <p:txBody>
-          <a:bodyPr wrap="square" lIns="0" tIns="0" rIns="0" bIns="0" rtlCol="0" anchor="t"/>
-          <a:lstStyle/>
-          <a:p>
-            <a:pPr indent="0" marL="0">
-              <a:spcAft>
-                <a:spcPts val="500"/>
-              </a:spcAft>
-              <a:buNone/>
-            </a:pPr>
-            <a:r>
-              <a:rPr lang="en-US" sz="1300" dirty="0">
-                <a:solidFill>
-                  <a:schemeClr val="tx1"/>
-                </a:solidFill>
-              </a:rPr>
-              <a:t>Better quality, better prices and new models.</a:t>
-            </a:r>
-            <a:endParaRPr lang="en-US" sz="1300" dirty="0"/>
-          </a:p>
-          <a:p>
-            <a:pPr indent="0" marL="0">
-              <a:spcAft>
-                <a:spcPts val="500"/>
-              </a:spcAft>
-              <a:buNone/>
-            </a:pPr>
-            <a:r>
-              <a:rPr lang="en-US" sz="1300" dirty="0">
-                <a:solidFill>
-                  <a:schemeClr val="accent6"/>
-                </a:solidFill>
-                <a:latin typeface="Microsoft YaHei" pitchFamily="34" charset="0"/>
-                <a:ea typeface="Microsoft YaHei" pitchFamily="34" charset="-122"/>
-                <a:cs typeface="Microsoft YaHei" pitchFamily="34" charset="-120"/>
-              </a:rPr>
-              <a:t>更好的品质、更优的价格和新款产品。</a:t>
-            </a:r>
-            <a:endParaRPr lang="en-US" sz="1300" dirty="0"/>
-          </a:p>
-        </p:txBody>
-      </p:sp>
-      <p:sp>
-        <p:nvSpPr>
-          <p:cNvPr id="20" name="Outcome box"/>
-          <p:cNvSpPr/>
-          <p:nvPr/>
-        </p:nvSpPr>
-        <p:spPr>
-          <a:xfrm>
-            <a:off x="548640" y="5212080"/>
-            <a:ext cx="11094415" cy="749808"/>
-          </a:xfrm>
-          <a:prstGeom prst="roundRect">
-            <a:avLst>
-              <a:gd name="adj" fmla="val 19512"/>
-            </a:avLst>
-          </a:prstGeom>
-          <a:solidFill>
-            <a:srgbClr val="EDE6DA"/>
+            <a:schemeClr val="accent2"/>
           </a:solidFill>
           <a:ln/>
         </p:spPr>
       </p:sp>
       <p:pic>
         <p:nvPicPr>
-          <p:cNvPr id="21" name="Outcome icon" descr="preencoded.png">    </p:cNvPr>
+          <p:cNvPr id="12" name="Plan icon 1" descr="preencoded.png">    </p:cNvPr>
           <p:cNvPicPr>
             <a:picLocks noChangeAspect="1"/>
           </p:cNvPicPr>
@@ -6664,8 +6229,8 @@
         </p:blipFill>
         <p:spPr>
           <a:xfrm>
-            <a:off x="804672" y="5413248"/>
-            <a:ext cx="347472" cy="347472"/>
+            <a:off x="4151376" y="2112264"/>
+            <a:ext cx="310896" cy="310896"/>
           </a:xfrm>
           <a:prstGeom prst="rect">
             <a:avLst/>
@@ -6674,14 +6239,14 @@
       </p:pic>
       <p:sp>
         <p:nvSpPr>
-          <p:cNvPr id="22" name="Outcome"/>
+          <p:cNvPr id="13" name="Plan number 1"/>
           <p:cNvSpPr txBox="1"/>
           <p:nvPr/>
         </p:nvSpPr>
         <p:spPr>
           <a:xfrm>
-            <a:off x="1325880" y="5321808"/>
-            <a:ext cx="10088575" cy="566928"/>
+            <a:off x="5240426" y="2011680"/>
+            <a:ext cx="685800" cy="502920"/>
           </a:xfrm>
           <a:prstGeom prst="rect">
             <a:avLst/>
@@ -6693,6 +6258,42 @@
           <a:bodyPr wrap="square" lIns="0" tIns="0" rIns="0" bIns="0" rtlCol="0" anchor="t"/>
           <a:lstStyle/>
           <a:p>
+            <a:pPr algn="r" indent="0" marL="0">
+              <a:buNone/>
+            </a:pPr>
+            <a:r>
+              <a:rPr lang="en-US" sz="2600" b="1" dirty="0">
+                <a:solidFill>
+                  <a:schemeClr val="accent2"/>
+                </a:solidFill>
+              </a:rPr>
+              <a:t>01</a:t>
+            </a:r>
+            <a:endParaRPr lang="en-US" sz="2600" dirty="0"/>
+          </a:p>
+        </p:txBody>
+      </p:sp>
+      <p:sp>
+        <p:nvSpPr>
+          <p:cNvPr id="14" name="Plan title 1"/>
+          <p:cNvSpPr txBox="1"/>
+          <p:nvPr/>
+        </p:nvSpPr>
+        <p:spPr>
+          <a:xfrm>
+            <a:off x="4023360" y="2715768"/>
+            <a:ext cx="1948586" cy="685800"/>
+          </a:xfrm>
+          <a:prstGeom prst="rect">
+            <a:avLst/>
+          </a:prstGeom>
+          <a:noFill/>
+          <a:ln/>
+        </p:spPr>
+        <p:txBody>
+          <a:bodyPr wrap="square" lIns="0" tIns="0" rIns="0" bIns="0" rtlCol="0" anchor="t"/>
+          <a:lstStyle/>
+          <a:p>
             <a:pPr indent="0" marL="0">
               <a:spcAft>
                 <a:spcPts val="200"/>
@@ -6700,13 +6301,16 @@
               <a:buNone/>
             </a:pPr>
             <a:r>
-              <a:rPr lang="en-US" sz="1300" b="1" dirty="0">
-                <a:solidFill>
-                  <a:schemeClr val="tx1"/>
-                </a:solidFill>
-              </a:rPr>
-              <a:t>A good visit: </a:t>
-            </a:r>
+              <a:rPr lang="en-US" sz="1700" b="1" dirty="0">
+                <a:solidFill>
+                  <a:schemeClr val="bg1"/>
+                </a:solidFill>
+              </a:rPr>
+              <a:t>Test small</a:t>
+            </a:r>
+            <a:endParaRPr lang="en-US" sz="1700" dirty="0"/>
+          </a:p>
+          <a:p>
             <a:pPr indent="0" marL="0">
               <a:spcAft>
                 <a:spcPts val="200"/>
@@ -6714,51 +6318,842 @@
               <a:buNone/>
             </a:pPr>
             <a:r>
-              <a:rPr lang="en-US" sz="1300" dirty="0">
-                <a:solidFill>
-                  <a:schemeClr val="tx1"/>
-                </a:solidFill>
-              </a:rPr>
-              <a:t>we leave with samples, your recommendations and clear next steps for 2027.</a:t>
-            </a:r>
-            <a:endParaRPr lang="en-US" sz="1300" dirty="0"/>
-          </a:p>
-          <a:p>
-            <a:pPr indent="0" marL="0">
-              <a:spcAft>
-                <a:spcPts val="200"/>
-              </a:spcAft>
-              <a:buNone/>
-            </a:pPr>
-            <a:r>
-              <a:rPr lang="en-US" sz="1300" b="1" dirty="0">
-                <a:solidFill>
-                  <a:schemeClr val="accent4"/>
+              <a:rPr lang="en-US" sz="1400" b="1" dirty="0">
+                <a:solidFill>
+                  <a:schemeClr val="accent2"/>
                 </a:solidFill>
                 <a:latin typeface="Microsoft YaHei" pitchFamily="34" charset="0"/>
                 <a:ea typeface="Microsoft YaHei" pitchFamily="34" charset="-122"/>
                 <a:cs typeface="Microsoft YaHei" pitchFamily="34" charset="-120"/>
               </a:rPr>
-              <a:t>成功的拜访：</a:t>
-            </a:r>
-            <a:pPr indent="0" marL="0">
-              <a:spcAft>
-                <a:spcPts val="200"/>
-              </a:spcAft>
-              <a:buNone/>
-            </a:pPr>
-            <a:r>
-              <a:rPr lang="en-US" sz="1300" dirty="0">
-                <a:solidFill>
-                  <a:schemeClr val="accent4"/>
+              <a:t>小批量试销</a:t>
+            </a:r>
+            <a:endParaRPr lang="en-US" sz="1700" dirty="0"/>
+          </a:p>
+        </p:txBody>
+      </p:sp>
+      <p:sp>
+        <p:nvSpPr>
+          <p:cNvPr id="15" name="Plan text 1"/>
+          <p:cNvSpPr txBox="1"/>
+          <p:nvPr/>
+        </p:nvSpPr>
+        <p:spPr>
+          <a:xfrm>
+            <a:off x="4023360" y="3493008"/>
+            <a:ext cx="1948586" cy="1143000"/>
+          </a:xfrm>
+          <a:prstGeom prst="rect">
+            <a:avLst/>
+          </a:prstGeom>
+          <a:noFill/>
+          <a:ln/>
+        </p:spPr>
+        <p:txBody>
+          <a:bodyPr wrap="square" lIns="0" tIns="0" rIns="0" bIns="0" rtlCol="0" anchor="t"/>
+          <a:lstStyle/>
+          <a:p>
+            <a:pPr indent="0" marL="0">
+              <a:spcAft>
+                <a:spcPts val="500"/>
+              </a:spcAft>
+              <a:buNone/>
+            </a:pPr>
+            <a:r>
+              <a:rPr lang="en-US" sz="1150" dirty="0">
+                <a:solidFill>
+                  <a:schemeClr val="bg1"/>
+                </a:solidFill>
+              </a:rPr>
+              <a:t>Low MOQ on the first order, so we can test many new products.</a:t>
+            </a:r>
+            <a:endParaRPr lang="en-US" sz="1150" dirty="0"/>
+          </a:p>
+          <a:p>
+            <a:pPr indent="0" marL="0">
+              <a:spcAft>
+                <a:spcPts val="500"/>
+              </a:spcAft>
+              <a:buNone/>
+            </a:pPr>
+            <a:r>
+              <a:rPr lang="en-US" sz="1050" dirty="0">
+                <a:solidFill>
+                  <a:schemeClr val="accent3"/>
                 </a:solidFill>
                 <a:latin typeface="Microsoft YaHei" pitchFamily="34" charset="0"/>
                 <a:ea typeface="Microsoft YaHei" pitchFamily="34" charset="-122"/>
                 <a:cs typeface="Microsoft YaHei" pitchFamily="34" charset="-120"/>
               </a:rPr>
-              <a:t>我们带着样品、您的建议和清晰的 2027 年下一步计划回去。</a:t>
-            </a:r>
-            <a:endParaRPr lang="en-US" sz="1300" dirty="0"/>
+              <a:t>首单低起订量，让我们能测试更多新品。</a:t>
+            </a:r>
+            <a:endParaRPr lang="en-US" sz="1150" dirty="0"/>
+          </a:p>
+        </p:txBody>
+      </p:sp>
+      <p:pic>
+        <p:nvPicPr>
+          <p:cNvPr id="16" name="Plan arrow 1" descr="preencoded.png">    </p:cNvPr>
+          <p:cNvPicPr>
+            <a:picLocks noChangeAspect="1"/>
+          </p:cNvPicPr>
+          <p:nvPr/>
+        </p:nvPicPr>
+        <p:blipFill>
+          <a:blip r:embed="rId2"/>
+          <a:stretch>
+            <a:fillRect/>
+          </a:stretch>
+        </p:blipFill>
+        <p:spPr>
+          <a:xfrm>
+            <a:off x="6209690" y="3104388"/>
+            <a:ext cx="274320" cy="274320"/>
+          </a:xfrm>
+          <a:prstGeom prst="rect">
+            <a:avLst/>
+          </a:prstGeom>
+        </p:spPr>
+      </p:pic>
+      <p:sp>
+        <p:nvSpPr>
+          <p:cNvPr id="17" name="Plan step 2"/>
+          <p:cNvSpPr/>
+          <p:nvPr/>
+        </p:nvSpPr>
+        <p:spPr>
+          <a:xfrm>
+            <a:off x="6538874" y="1755648"/>
+            <a:ext cx="2360066" cy="2971800"/>
+          </a:xfrm>
+          <a:prstGeom prst="roundRect">
+            <a:avLst>
+              <a:gd name="adj" fmla="val 6199"/>
+            </a:avLst>
+          </a:prstGeom>
+          <a:solidFill>
+            <a:srgbClr val="24221F"/>
+          </a:solidFill>
+          <a:ln/>
+        </p:spPr>
+      </p:sp>
+      <p:sp>
+        <p:nvSpPr>
+          <p:cNvPr id="18" name="Plan badge 2"/>
+          <p:cNvSpPr/>
+          <p:nvPr/>
+        </p:nvSpPr>
+        <p:spPr>
+          <a:xfrm>
+            <a:off x="6767474" y="1984248"/>
+            <a:ext cx="566928" cy="566928"/>
+          </a:xfrm>
+          <a:prstGeom prst="ellipse">
+            <a:avLst/>
+          </a:prstGeom>
+          <a:solidFill>
+            <a:schemeClr val="accent2"/>
+          </a:solidFill>
+          <a:ln/>
+        </p:spPr>
+      </p:sp>
+      <p:pic>
+        <p:nvPicPr>
+          <p:cNvPr id="19" name="Plan icon 2" descr="preencoded.png">    </p:cNvPr>
+          <p:cNvPicPr>
+            <a:picLocks noChangeAspect="1"/>
+          </p:cNvPicPr>
+          <p:nvPr/>
+        </p:nvPicPr>
+        <p:blipFill>
+          <a:blip r:embed="rId3"/>
+          <a:stretch>
+            <a:fillRect/>
+          </a:stretch>
+        </p:blipFill>
+        <p:spPr>
+          <a:xfrm>
+            <a:off x="6895490" y="2112264"/>
+            <a:ext cx="310896" cy="310896"/>
+          </a:xfrm>
+          <a:prstGeom prst="rect">
+            <a:avLst/>
+          </a:prstGeom>
+        </p:spPr>
+      </p:pic>
+      <p:sp>
+        <p:nvSpPr>
+          <p:cNvPr id="20" name="Plan number 2"/>
+          <p:cNvSpPr txBox="1"/>
+          <p:nvPr/>
+        </p:nvSpPr>
+        <p:spPr>
+          <a:xfrm>
+            <a:off x="7984541" y="2011680"/>
+            <a:ext cx="685800" cy="502920"/>
+          </a:xfrm>
+          <a:prstGeom prst="rect">
+            <a:avLst/>
+          </a:prstGeom>
+          <a:noFill/>
+          <a:ln/>
+        </p:spPr>
+        <p:txBody>
+          <a:bodyPr wrap="square" lIns="0" tIns="0" rIns="0" bIns="0" rtlCol="0" anchor="t"/>
+          <a:lstStyle/>
+          <a:p>
+            <a:pPr algn="r" indent="0" marL="0">
+              <a:buNone/>
+            </a:pPr>
+            <a:r>
+              <a:rPr lang="en-US" sz="2600" b="1" dirty="0">
+                <a:solidFill>
+                  <a:schemeClr val="accent2"/>
+                </a:solidFill>
+              </a:rPr>
+              <a:t>02</a:t>
+            </a:r>
+            <a:endParaRPr lang="en-US" sz="2600" dirty="0"/>
+          </a:p>
+        </p:txBody>
+      </p:sp>
+      <p:sp>
+        <p:nvSpPr>
+          <p:cNvPr id="21" name="Plan title 2"/>
+          <p:cNvSpPr txBox="1"/>
+          <p:nvPr/>
+        </p:nvSpPr>
+        <p:spPr>
+          <a:xfrm>
+            <a:off x="6767474" y="2715768"/>
+            <a:ext cx="1948586" cy="685800"/>
+          </a:xfrm>
+          <a:prstGeom prst="rect">
+            <a:avLst/>
+          </a:prstGeom>
+          <a:noFill/>
+          <a:ln/>
+        </p:spPr>
+        <p:txBody>
+          <a:bodyPr wrap="square" lIns="0" tIns="0" rIns="0" bIns="0" rtlCol="0" anchor="t"/>
+          <a:lstStyle/>
+          <a:p>
+            <a:pPr indent="0" marL="0">
+              <a:spcAft>
+                <a:spcPts val="200"/>
+              </a:spcAft>
+              <a:buNone/>
+            </a:pPr>
+            <a:r>
+              <a:rPr lang="en-US" sz="1700" b="1" dirty="0">
+                <a:solidFill>
+                  <a:schemeClr val="bg1"/>
+                </a:solidFill>
+              </a:rPr>
+              <a:t>Learn fast</a:t>
+            </a:r>
+            <a:endParaRPr lang="en-US" sz="1700" dirty="0"/>
+          </a:p>
+          <a:p>
+            <a:pPr indent="0" marL="0">
+              <a:spcAft>
+                <a:spcPts val="200"/>
+              </a:spcAft>
+              <a:buNone/>
+            </a:pPr>
+            <a:r>
+              <a:rPr lang="en-US" sz="1400" b="1" dirty="0">
+                <a:solidFill>
+                  <a:schemeClr val="accent2"/>
+                </a:solidFill>
+                <a:latin typeface="Microsoft YaHei" pitchFamily="34" charset="0"/>
+                <a:ea typeface="Microsoft YaHei" pitchFamily="34" charset="-122"/>
+                <a:cs typeface="Microsoft YaHei" pitchFamily="34" charset="-120"/>
+              </a:rPr>
+              <a:t>快速验证市场</a:t>
+            </a:r>
+            <a:endParaRPr lang="en-US" sz="1700" dirty="0"/>
+          </a:p>
+        </p:txBody>
+      </p:sp>
+      <p:sp>
+        <p:nvSpPr>
+          <p:cNvPr id="22" name="Plan text 2"/>
+          <p:cNvSpPr txBox="1"/>
+          <p:nvPr/>
+        </p:nvSpPr>
+        <p:spPr>
+          <a:xfrm>
+            <a:off x="6767474" y="3493008"/>
+            <a:ext cx="1948586" cy="1143000"/>
+          </a:xfrm>
+          <a:prstGeom prst="rect">
+            <a:avLst/>
+          </a:prstGeom>
+          <a:noFill/>
+          <a:ln/>
+        </p:spPr>
+        <p:txBody>
+          <a:bodyPr wrap="square" lIns="0" tIns="0" rIns="0" bIns="0" rtlCol="0" anchor="t"/>
+          <a:lstStyle/>
+          <a:p>
+            <a:pPr indent="0" marL="0">
+              <a:spcAft>
+                <a:spcPts val="500"/>
+              </a:spcAft>
+              <a:buNone/>
+            </a:pPr>
+            <a:r>
+              <a:rPr lang="en-US" sz="1150" dirty="0">
+                <a:solidFill>
+                  <a:schemeClr val="bg1"/>
+                </a:solidFill>
+              </a:rPr>
+              <a:t>Fast samples and short lead times. Our sales data quickly shows what works.</a:t>
+            </a:r>
+            <a:endParaRPr lang="en-US" sz="1150" dirty="0"/>
+          </a:p>
+          <a:p>
+            <a:pPr indent="0" marL="0">
+              <a:spcAft>
+                <a:spcPts val="500"/>
+              </a:spcAft>
+              <a:buNone/>
+            </a:pPr>
+            <a:r>
+              <a:rPr lang="en-US" sz="1050" dirty="0">
+                <a:solidFill>
+                  <a:schemeClr val="accent3"/>
+                </a:solidFill>
+                <a:latin typeface="Microsoft YaHei" pitchFamily="34" charset="0"/>
+                <a:ea typeface="Microsoft YaHei" pitchFamily="34" charset="-122"/>
+                <a:cs typeface="Microsoft YaHei" pitchFamily="34" charset="-120"/>
+              </a:rPr>
+              <a:t>快速打样，交期短。我们的销售数据能很快显示哪款产品受欢迎。</a:t>
+            </a:r>
+            <a:endParaRPr lang="en-US" sz="1150" dirty="0"/>
+          </a:p>
+        </p:txBody>
+      </p:sp>
+      <p:pic>
+        <p:nvPicPr>
+          <p:cNvPr id="23" name="Plan arrow 2" descr="preencoded.png">    </p:cNvPr>
+          <p:cNvPicPr>
+            <a:picLocks noChangeAspect="1"/>
+          </p:cNvPicPr>
+          <p:nvPr/>
+        </p:nvPicPr>
+        <p:blipFill>
+          <a:blip r:embed="rId4"/>
+          <a:stretch>
+            <a:fillRect/>
+          </a:stretch>
+        </p:blipFill>
+        <p:spPr>
+          <a:xfrm>
+            <a:off x="8953805" y="3104388"/>
+            <a:ext cx="274320" cy="274320"/>
+          </a:xfrm>
+          <a:prstGeom prst="rect">
+            <a:avLst/>
+          </a:prstGeom>
+        </p:spPr>
+      </p:pic>
+      <p:sp>
+        <p:nvSpPr>
+          <p:cNvPr id="24" name="Plan step 3"/>
+          <p:cNvSpPr/>
+          <p:nvPr/>
+        </p:nvSpPr>
+        <p:spPr>
+          <a:xfrm>
+            <a:off x="9282989" y="1755648"/>
+            <a:ext cx="2360066" cy="2971800"/>
+          </a:xfrm>
+          <a:prstGeom prst="roundRect">
+            <a:avLst>
+              <a:gd name="adj" fmla="val 6199"/>
+            </a:avLst>
+          </a:prstGeom>
+          <a:solidFill>
+            <a:srgbClr val="24221F"/>
+          </a:solidFill>
+          <a:ln/>
+        </p:spPr>
+      </p:sp>
+      <p:sp>
+        <p:nvSpPr>
+          <p:cNvPr id="25" name="Plan badge 3"/>
+          <p:cNvSpPr/>
+          <p:nvPr/>
+        </p:nvSpPr>
+        <p:spPr>
+          <a:xfrm>
+            <a:off x="9511589" y="1984248"/>
+            <a:ext cx="566928" cy="566928"/>
+          </a:xfrm>
+          <a:prstGeom prst="ellipse">
+            <a:avLst/>
+          </a:prstGeom>
+          <a:solidFill>
+            <a:schemeClr val="accent2"/>
+          </a:solidFill>
+          <a:ln/>
+        </p:spPr>
+      </p:sp>
+      <p:pic>
+        <p:nvPicPr>
+          <p:cNvPr id="26" name="Plan icon 3" descr="preencoded.png">    </p:cNvPr>
+          <p:cNvPicPr>
+            <a:picLocks noChangeAspect="1"/>
+          </p:cNvPicPr>
+          <p:nvPr/>
+        </p:nvPicPr>
+        <p:blipFill>
+          <a:blip r:embed="rId5"/>
+          <a:stretch>
+            <a:fillRect/>
+          </a:stretch>
+        </p:blipFill>
+        <p:spPr>
+          <a:xfrm>
+            <a:off x="9639605" y="2112264"/>
+            <a:ext cx="310896" cy="310896"/>
+          </a:xfrm>
+          <a:prstGeom prst="rect">
+            <a:avLst/>
+          </a:prstGeom>
+        </p:spPr>
+      </p:pic>
+      <p:sp>
+        <p:nvSpPr>
+          <p:cNvPr id="27" name="Plan number 3"/>
+          <p:cNvSpPr txBox="1"/>
+          <p:nvPr/>
+        </p:nvSpPr>
+        <p:spPr>
+          <a:xfrm>
+            <a:off x="10728655" y="2011680"/>
+            <a:ext cx="685800" cy="502920"/>
+          </a:xfrm>
+          <a:prstGeom prst="rect">
+            <a:avLst/>
+          </a:prstGeom>
+          <a:noFill/>
+          <a:ln/>
+        </p:spPr>
+        <p:txBody>
+          <a:bodyPr wrap="square" lIns="0" tIns="0" rIns="0" bIns="0" rtlCol="0" anchor="t"/>
+          <a:lstStyle/>
+          <a:p>
+            <a:pPr algn="r" indent="0" marL="0">
+              <a:buNone/>
+            </a:pPr>
+            <a:r>
+              <a:rPr lang="en-US" sz="2600" b="1" dirty="0">
+                <a:solidFill>
+                  <a:schemeClr val="accent2"/>
+                </a:solidFill>
+              </a:rPr>
+              <a:t>03</a:t>
+            </a:r>
+            <a:endParaRPr lang="en-US" sz="2600" dirty="0"/>
+          </a:p>
+        </p:txBody>
+      </p:sp>
+      <p:sp>
+        <p:nvSpPr>
+          <p:cNvPr id="28" name="Plan title 3"/>
+          <p:cNvSpPr txBox="1"/>
+          <p:nvPr/>
+        </p:nvSpPr>
+        <p:spPr>
+          <a:xfrm>
+            <a:off x="9511589" y="2715768"/>
+            <a:ext cx="1948586" cy="685800"/>
+          </a:xfrm>
+          <a:prstGeom prst="rect">
+            <a:avLst/>
+          </a:prstGeom>
+          <a:noFill/>
+          <a:ln/>
+        </p:spPr>
+        <p:txBody>
+          <a:bodyPr wrap="square" lIns="0" tIns="0" rIns="0" bIns="0" rtlCol="0" anchor="t"/>
+          <a:lstStyle/>
+          <a:p>
+            <a:pPr indent="0" marL="0">
+              <a:spcAft>
+                <a:spcPts val="200"/>
+              </a:spcAft>
+              <a:buNone/>
+            </a:pPr>
+            <a:r>
+              <a:rPr lang="en-US" sz="1700" b="1" dirty="0">
+                <a:solidFill>
+                  <a:schemeClr val="bg1"/>
+                </a:solidFill>
+              </a:rPr>
+              <a:t>Scale big</a:t>
+            </a:r>
+            <a:endParaRPr lang="en-US" sz="1700" dirty="0"/>
+          </a:p>
+          <a:p>
+            <a:pPr indent="0" marL="0">
+              <a:spcAft>
+                <a:spcPts val="200"/>
+              </a:spcAft>
+              <a:buNone/>
+            </a:pPr>
+            <a:r>
+              <a:rPr lang="en-US" sz="1400" b="1" dirty="0">
+                <a:solidFill>
+                  <a:schemeClr val="accent2"/>
+                </a:solidFill>
+                <a:latin typeface="Microsoft YaHei" pitchFamily="34" charset="0"/>
+                <a:ea typeface="Microsoft YaHei" pitchFamily="34" charset="-122"/>
+                <a:cs typeface="Microsoft YaHei" pitchFamily="34" charset="-120"/>
+              </a:rPr>
+              <a:t>迅速放量</a:t>
+            </a:r>
+            <a:endParaRPr lang="en-US" sz="1700" dirty="0"/>
+          </a:p>
+        </p:txBody>
+      </p:sp>
+      <p:sp>
+        <p:nvSpPr>
+          <p:cNvPr id="29" name="Plan text 3"/>
+          <p:cNvSpPr txBox="1"/>
+          <p:nvPr/>
+        </p:nvSpPr>
+        <p:spPr>
+          <a:xfrm>
+            <a:off x="9511589" y="3493008"/>
+            <a:ext cx="1948586" cy="1143000"/>
+          </a:xfrm>
+          <a:prstGeom prst="rect">
+            <a:avLst/>
+          </a:prstGeom>
+          <a:noFill/>
+          <a:ln/>
+        </p:spPr>
+        <p:txBody>
+          <a:bodyPr wrap="square" lIns="0" tIns="0" rIns="0" bIns="0" rtlCol="0" anchor="t"/>
+          <a:lstStyle/>
+          <a:p>
+            <a:pPr indent="0" marL="0">
+              <a:spcAft>
+                <a:spcPts val="500"/>
+              </a:spcAft>
+              <a:buNone/>
+            </a:pPr>
+            <a:r>
+              <a:rPr lang="en-US" sz="1150" dirty="0">
+                <a:solidFill>
+                  <a:schemeClr val="bg1"/>
+                </a:solidFill>
+              </a:rPr>
+              <a:t>When a product takes off, we go all in with large bulk orders straight away.</a:t>
+            </a:r>
+            <a:endParaRPr lang="en-US" sz="1150" dirty="0"/>
+          </a:p>
+          <a:p>
+            <a:pPr indent="0" marL="0">
+              <a:spcAft>
+                <a:spcPts val="500"/>
+              </a:spcAft>
+              <a:buNone/>
+            </a:pPr>
+            <a:r>
+              <a:rPr lang="en-US" sz="1050" dirty="0">
+                <a:solidFill>
+                  <a:schemeClr val="accent3"/>
+                </a:solidFill>
+                <a:latin typeface="Microsoft YaHei" pitchFamily="34" charset="0"/>
+                <a:ea typeface="Microsoft YaHei" pitchFamily="34" charset="-122"/>
+                <a:cs typeface="Microsoft YaHei" pitchFamily="34" charset="-120"/>
+              </a:rPr>
+              <a:t>产品一旦畅销，我们立即全力跟进，下大批量订单。</a:t>
+            </a:r>
+            <a:endParaRPr lang="en-US" sz="1150" dirty="0"/>
+          </a:p>
+        </p:txBody>
+      </p:sp>
+      <p:sp>
+        <p:nvSpPr>
+          <p:cNvPr id="30" name="Plan box 1"/>
+          <p:cNvSpPr/>
+          <p:nvPr/>
+        </p:nvSpPr>
+        <p:spPr>
+          <a:xfrm>
+            <a:off x="548640" y="4956048"/>
+            <a:ext cx="5410048" cy="1216152"/>
+          </a:xfrm>
+          <a:prstGeom prst="roundRect">
+            <a:avLst>
+              <a:gd name="adj" fmla="val 12030"/>
+            </a:avLst>
+          </a:prstGeom>
+          <a:solidFill>
+            <a:srgbClr val="24221F"/>
+          </a:solidFill>
+          <a:ln/>
+        </p:spPr>
+      </p:sp>
+      <p:pic>
+        <p:nvPicPr>
+          <p:cNvPr id="31" name="Plan box icon 1" descr="preencoded.png">    </p:cNvPr>
+          <p:cNvPicPr>
+            <a:picLocks noChangeAspect="1"/>
+          </p:cNvPicPr>
+          <p:nvPr/>
+        </p:nvPicPr>
+        <p:blipFill>
+          <a:blip r:embed="rId6"/>
+          <a:stretch>
+            <a:fillRect/>
+          </a:stretch>
+        </p:blipFill>
+        <p:spPr>
+          <a:xfrm>
+            <a:off x="777240" y="5157216"/>
+            <a:ext cx="347472" cy="347472"/>
+          </a:xfrm>
+          <a:prstGeom prst="rect">
+            <a:avLst/>
+          </a:prstGeom>
+        </p:spPr>
+      </p:pic>
+      <p:sp>
+        <p:nvSpPr>
+          <p:cNvPr id="32" name="Plan box text 1"/>
+          <p:cNvSpPr txBox="1"/>
+          <p:nvPr/>
+        </p:nvSpPr>
+        <p:spPr>
+          <a:xfrm>
+            <a:off x="1280160" y="5084064"/>
+            <a:ext cx="4495648" cy="960120"/>
+          </a:xfrm>
+          <a:prstGeom prst="rect">
+            <a:avLst/>
+          </a:prstGeom>
+          <a:noFill/>
+          <a:ln/>
+        </p:spPr>
+        <p:txBody>
+          <a:bodyPr wrap="square" lIns="0" tIns="0" rIns="0" bIns="0" rtlCol="0" anchor="t"/>
+          <a:lstStyle/>
+          <a:p>
+            <a:pPr indent="0" marL="0">
+              <a:spcAft>
+                <a:spcPts val="300"/>
+              </a:spcAft>
+              <a:buNone/>
+            </a:pPr>
+            <a:r>
+              <a:rPr lang="en-US" sz="1300" b="1" dirty="0">
+                <a:solidFill>
+                  <a:schemeClr val="accent2"/>
+                </a:solidFill>
+              </a:rPr>
+              <a:t>What we ask from you</a:t>
+            </a:r>
+            <a:pPr indent="0" marL="0">
+              <a:spcAft>
+                <a:spcPts val="300"/>
+              </a:spcAft>
+              <a:buNone/>
+            </a:pPr>
+            <a:r>
+              <a:rPr lang="en-US" sz="1200" b="1" dirty="0">
+                <a:solidFill>
+                  <a:schemeClr val="accent2"/>
+                </a:solidFill>
+                <a:latin typeface="Microsoft YaHei" pitchFamily="34" charset="0"/>
+                <a:ea typeface="Microsoft YaHei" pitchFamily="34" charset="-122"/>
+                <a:cs typeface="Microsoft YaHei" pitchFamily="34" charset="-120"/>
+              </a:rPr>
+              <a:t>  ·  我们希望贵司做到的</a:t>
+            </a:r>
+            <a:endParaRPr lang="en-US" sz="1150" dirty="0"/>
+          </a:p>
+          <a:p>
+            <a:pPr indent="0" marL="0">
+              <a:spcAft>
+                <a:spcPts val="300"/>
+              </a:spcAft>
+              <a:buNone/>
+            </a:pPr>
+            <a:r>
+              <a:rPr lang="en-US" sz="1150" dirty="0">
+                <a:solidFill>
+                  <a:schemeClr val="bg1"/>
+                </a:solidFill>
+              </a:rPr>
+              <a:t>Lower MOQs for test orders, fast samples, short lead times and room to scale up quickly.</a:t>
+            </a:r>
+            <a:endParaRPr lang="en-US" sz="1150" dirty="0"/>
+          </a:p>
+          <a:p>
+            <a:pPr indent="0" marL="0">
+              <a:spcAft>
+                <a:spcPts val="300"/>
+              </a:spcAft>
+              <a:buNone/>
+            </a:pPr>
+            <a:r>
+              <a:rPr lang="en-US" sz="1050" dirty="0">
+                <a:solidFill>
+                  <a:schemeClr val="accent3"/>
+                </a:solidFill>
+                <a:latin typeface="Microsoft YaHei" pitchFamily="34" charset="0"/>
+                <a:ea typeface="Microsoft YaHei" pitchFamily="34" charset="-122"/>
+                <a:cs typeface="Microsoft YaHei" pitchFamily="34" charset="-120"/>
+              </a:rPr>
+              <a:t>试销订单降低起订量，快速打样，缩短交期，并能快速扩大产能。</a:t>
+            </a:r>
+            <a:endParaRPr lang="en-US" sz="1150" dirty="0"/>
+          </a:p>
+        </p:txBody>
+      </p:sp>
+      <p:sp>
+        <p:nvSpPr>
+          <p:cNvPr id="33" name="Plan box 2"/>
+          <p:cNvSpPr/>
+          <p:nvPr/>
+        </p:nvSpPr>
+        <p:spPr>
+          <a:xfrm>
+            <a:off x="6233008" y="4956048"/>
+            <a:ext cx="5410048" cy="1216152"/>
+          </a:xfrm>
+          <a:prstGeom prst="roundRect">
+            <a:avLst>
+              <a:gd name="adj" fmla="val 12030"/>
+            </a:avLst>
+          </a:prstGeom>
+          <a:solidFill>
+            <a:srgbClr val="24221F"/>
+          </a:solidFill>
+          <a:ln/>
+        </p:spPr>
+      </p:sp>
+      <p:pic>
+        <p:nvPicPr>
+          <p:cNvPr id="34" name="Plan box icon 2" descr="preencoded.png">    </p:cNvPr>
+          <p:cNvPicPr>
+            <a:picLocks noChangeAspect="1"/>
+          </p:cNvPicPr>
+          <p:nvPr/>
+        </p:nvPicPr>
+        <p:blipFill>
+          <a:blip r:embed="rId7"/>
+          <a:stretch>
+            <a:fillRect/>
+          </a:stretch>
+        </p:blipFill>
+        <p:spPr>
+          <a:xfrm>
+            <a:off x="6461608" y="5157216"/>
+            <a:ext cx="347472" cy="347472"/>
+          </a:xfrm>
+          <a:prstGeom prst="rect">
+            <a:avLst/>
+          </a:prstGeom>
+        </p:spPr>
+      </p:pic>
+      <p:sp>
+        <p:nvSpPr>
+          <p:cNvPr id="35" name="Plan box text 2"/>
+          <p:cNvSpPr txBox="1"/>
+          <p:nvPr/>
+        </p:nvSpPr>
+        <p:spPr>
+          <a:xfrm>
+            <a:off x="6964528" y="5084064"/>
+            <a:ext cx="4495648" cy="960120"/>
+          </a:xfrm>
+          <a:prstGeom prst="rect">
+            <a:avLst/>
+          </a:prstGeom>
+          <a:noFill/>
+          <a:ln/>
+        </p:spPr>
+        <p:txBody>
+          <a:bodyPr wrap="square" lIns="0" tIns="0" rIns="0" bIns="0" rtlCol="0" anchor="t"/>
+          <a:lstStyle/>
+          <a:p>
+            <a:pPr indent="0" marL="0">
+              <a:spcAft>
+                <a:spcPts val="300"/>
+              </a:spcAft>
+              <a:buNone/>
+            </a:pPr>
+            <a:r>
+              <a:rPr lang="en-US" sz="1300" b="1" dirty="0">
+                <a:solidFill>
+                  <a:schemeClr val="accent2"/>
+                </a:solidFill>
+              </a:rPr>
+              <a:t>What it means for you</a:t>
+            </a:r>
+            <a:pPr indent="0" marL="0">
+              <a:spcAft>
+                <a:spcPts val="300"/>
+              </a:spcAft>
+              <a:buNone/>
+            </a:pPr>
+            <a:r>
+              <a:rPr lang="en-US" sz="1200" b="1" dirty="0">
+                <a:solidFill>
+                  <a:schemeClr val="accent2"/>
+                </a:solidFill>
+                <a:latin typeface="Microsoft YaHei" pitchFamily="34" charset="0"/>
+                <a:ea typeface="Microsoft YaHei" pitchFamily="34" charset="-122"/>
+                <a:cs typeface="Microsoft YaHei" pitchFamily="34" charset="-120"/>
+              </a:rPr>
+              <a:t>  ·  对贵司的意义</a:t>
+            </a:r>
+            <a:endParaRPr lang="en-US" sz="1150" dirty="0"/>
+          </a:p>
+          <a:p>
+            <a:pPr indent="0" marL="0">
+              <a:spcAft>
+                <a:spcPts val="300"/>
+              </a:spcAft>
+              <a:buNone/>
+            </a:pPr>
+            <a:r>
+              <a:rPr lang="en-US" sz="1150" dirty="0">
+                <a:solidFill>
+                  <a:schemeClr val="bg1"/>
+                </a:solidFill>
+              </a:rPr>
+              <a:t>More new products every month, and every winner becomes a large repeat order.</a:t>
+            </a:r>
+            <a:endParaRPr lang="en-US" sz="1150" dirty="0"/>
+          </a:p>
+          <a:p>
+            <a:pPr indent="0" marL="0">
+              <a:spcAft>
+                <a:spcPts val="300"/>
+              </a:spcAft>
+              <a:buNone/>
+            </a:pPr>
+            <a:r>
+              <a:rPr lang="en-US" sz="1050" dirty="0">
+                <a:solidFill>
+                  <a:schemeClr val="accent3"/>
+                </a:solidFill>
+                <a:latin typeface="Microsoft YaHei" pitchFamily="34" charset="0"/>
+                <a:ea typeface="Microsoft YaHei" pitchFamily="34" charset="-122"/>
+                <a:cs typeface="Microsoft YaHei" pitchFamily="34" charset="-120"/>
+              </a:rPr>
+              <a:t>每月更多新品订单，每一款爆品都会变成大批量的持续返单。</a:t>
+            </a:r>
+            <a:endParaRPr lang="en-US" sz="1150" dirty="0"/>
           </a:p>
         </p:txBody>
       </p:sp>
@@ -6792,7 +7187,7 @@
             <a:lvl1pPr>
               <a:defRPr sz="1000">
                 <a:solidFill>
-                  <a:schemeClr val="accent6"/>
+                  <a:schemeClr val="accent3"/>
                 </a:solidFill>
               </a:defRPr>
             </a:lvl1pPr>
@@ -11617,7 +12012,7 @@
                   <a:schemeClr val="bg1"/>
                 </a:solidFill>
               </a:rPr>
-              <a:t>What sells well in other markets? Which new features can you offer us?</a:t>
+              <a:t>What sells well in other markets? Which new products and features can you offer us for 2027?</a:t>
             </a:r>
             <a:endParaRPr lang="en-US" sz="1800" dirty="0"/>
           </a:p>
@@ -11637,7 +12032,7 @@
                 <a:ea typeface="Microsoft YaHei" pitchFamily="34" charset="-122"/>
                 <a:cs typeface="Microsoft YaHei" pitchFamily="34" charset="-120"/>
               </a:rPr>
-              <a:t>哪些产品在其他市场卖得好？贵司能为我们提供哪些新功能？</a:t>
+              <a:t>其他市场什么卖得好？贵司 2027 年有哪些新品和新功能？</a:t>
             </a:r>
             <a:endParaRPr lang="en-US" sz="1800" dirty="0"/>
           </a:p>

</xml_diff>